<commit_message>
Fix Maestro onboarding test
</commit_message>
<xml_diff>
--- a/Mausam-BugNotFound-Idea-Presentation.pptx
+++ b/Mausam-BugNotFound-Idea-Presentation.pptx
@@ -5,7 +5,7 @@
     <p:sldMasterId id="2147483648" r:id="rId1"/>
   </p:sldMasterIdLst>
   <p:notesMasterIdLst>
-    <p:notesMasterId r:id="rId9"/>
+    <p:notesMasterId r:id="rId8"/>
   </p:notesMasterIdLst>
   <p:sldIdLst>
     <p:sldId id="291" r:id="rId2"/>
@@ -261,7 +261,7 @@
             <a:fld id="{C4D5ADD5-2BBC-4A94-8F86-D9013941F742}" type="datetimeFigureOut">
               <a:rPr lang="en-US"/>
               <a:pPr/>
-              <a:t>6/2/2026</a:t>
+              <a:t>9/2/2026</a:t>
             </a:fld>
             <a:endParaRPr lang="en-US"/>
           </a:p>
@@ -1534,7 +1534,7 @@
           <a:p>
             <a:fld id="{E60792E3-D524-454C-8AFD-A91972900BCB}" type="datetime1">
               <a:rPr lang="en-US" smtClean="0"/>
-              <a:t>6/2/2026</a:t>
+              <a:t>9/2/2026</a:t>
             </a:fld>
             <a:endParaRPr lang="en-US"/>
           </a:p>
@@ -1716,7 +1716,7 @@
           <a:p>
             <a:fld id="{053C3A68-6922-42D3-8905-ECC2D82A3469}" type="datetime1">
               <a:rPr lang="en-US" smtClean="0"/>
-              <a:t>6/2/2026</a:t>
+              <a:t>9/2/2026</a:t>
             </a:fld>
             <a:endParaRPr lang="en-US"/>
           </a:p>
@@ -1908,7 +1908,7 @@
           <a:p>
             <a:fld id="{CB69E9F4-7604-4950-A8B2-8ACDEDB1506E}" type="datetime1">
               <a:rPr lang="en-US" smtClean="0"/>
-              <a:t>6/2/2026</a:t>
+              <a:t>9/2/2026</a:t>
             </a:fld>
             <a:endParaRPr lang="en-US"/>
           </a:p>
@@ -2090,7 +2090,7 @@
           <a:p>
             <a:fld id="{708B7524-32A2-4C20-A58C-BC3BAA1042FC}" type="datetime1">
               <a:rPr lang="en-US" smtClean="0"/>
-              <a:t>6/2/2026</a:t>
+              <a:t>9/2/2026</a:t>
             </a:fld>
             <a:endParaRPr lang="en-US"/>
           </a:p>
@@ -2349,7 +2349,7 @@
           <a:p>
             <a:fld id="{1E994447-D6B2-43BB-A877-57F1A267B999}" type="datetime1">
               <a:rPr lang="en-US" smtClean="0"/>
-              <a:t>6/2/2026</a:t>
+              <a:t>9/2/2026</a:t>
             </a:fld>
             <a:endParaRPr lang="en-US"/>
           </a:p>
@@ -2648,7 +2648,7 @@
           <a:p>
             <a:fld id="{68920E16-BD35-483C-AA6B-346FC7E46DEA}" type="datetime1">
               <a:rPr lang="en-US" smtClean="0"/>
-              <a:t>6/2/2026</a:t>
+              <a:t>9/2/2026</a:t>
             </a:fld>
             <a:endParaRPr lang="en-US"/>
           </a:p>
@@ -3081,7 +3081,7 @@
           <a:p>
             <a:fld id="{2FEAC6F8-5103-4FC0-A69E-5C6AE6469DA8}" type="datetime1">
               <a:rPr lang="en-US" smtClean="0"/>
-              <a:t>6/2/2026</a:t>
+              <a:t>9/2/2026</a:t>
             </a:fld>
             <a:endParaRPr lang="en-US"/>
           </a:p>
@@ -3212,7 +3212,7 @@
           <a:p>
             <a:fld id="{C60C6921-0627-4C8F-83D5-0CF936D2FFDD}" type="datetime1">
               <a:rPr lang="en-US" smtClean="0"/>
-              <a:t>6/2/2026</a:t>
+              <a:t>9/2/2026</a:t>
             </a:fld>
             <a:endParaRPr lang="en-US"/>
           </a:p>
@@ -3321,7 +3321,7 @@
           <a:p>
             <a:fld id="{2FF08AD7-8103-40F8-983C-E2BA6BB9CBE0}" type="datetime1">
               <a:rPr lang="en-US" smtClean="0"/>
-              <a:t>6/2/2026</a:t>
+              <a:t>9/2/2026</a:t>
             </a:fld>
             <a:endParaRPr lang="en-US"/>
           </a:p>
@@ -3610,7 +3610,7 @@
           <a:p>
             <a:fld id="{DF8C06B4-9380-4A4D-AF49-A3596E17DAF5}" type="datetime1">
               <a:rPr lang="en-US" smtClean="0"/>
-              <a:t>6/2/2026</a:t>
+              <a:t>9/2/2026</a:t>
             </a:fld>
             <a:endParaRPr lang="en-US"/>
           </a:p>
@@ -3879,7 +3879,7 @@
           <a:p>
             <a:fld id="{EF7FDEF1-C582-4E22-9E77-D68326471F28}" type="datetime1">
               <a:rPr lang="en-US" smtClean="0"/>
-              <a:t>6/2/2026</a:t>
+              <a:t>9/2/2026</a:t>
             </a:fld>
             <a:endParaRPr lang="en-US"/>
           </a:p>
@@ -4122,7 +4122,7 @@
           <a:p>
             <a:fld id="{780A9602-A9A9-453F-AEF1-37B5837E02CD}" type="datetime1">
               <a:rPr lang="en-US" smtClean="0"/>
-              <a:t>6/2/2026</a:t>
+              <a:t>9/2/2026</a:t>
             </a:fld>
             <a:endParaRPr lang="en-US"/>
           </a:p>
@@ -4673,7 +4673,7 @@
                 <a16:creationId xmlns:a16="http://schemas.microsoft.com/office/drawing/2014/main" id="{3E443FD7-A66B-4AA0-872D-B088B9BC5F17}"/>
               </a:ext>
               <a:ext uri="{C183D7F6-B498-43B3-948B-1728B52AA6E4}">
-                <adec:decorative xmlns:adec="http://schemas.microsoft.com/office/drawing/2017/decorative" xmlns="" val="1"/>
+                <adec:decorative xmlns:adec="http://schemas.microsoft.com/office/drawing/2017/decorative" val="1"/>
               </a:ext>
             </a:extLst>
           </p:cNvPr>
@@ -4733,7 +4733,7 @@
                 <a16:creationId xmlns:a16="http://schemas.microsoft.com/office/drawing/2014/main" id="{C04BE0EF-3561-49B4-9A29-F283168A91C7}"/>
               </a:ext>
               <a:ext uri="{C183D7F6-B498-43B3-948B-1728B52AA6E4}">
-                <adec:decorative xmlns:adec="http://schemas.microsoft.com/office/drawing/2017/decorative" xmlns="" val="1"/>
+                <adec:decorative xmlns:adec="http://schemas.microsoft.com/office/drawing/2017/decorative" val="1"/>
               </a:ext>
             </a:extLst>
           </p:cNvPr>
@@ -5600,16 +5600,7 @@
                 </a:solidFill>
                 <a:latin typeface="Garamond" panose="02020404030301010803" pitchFamily="18" charset="0"/>
               </a:rPr>
-              <a:t>SMART INDIA HACKATHON </a:t>
-            </a:r>
-            <a:r>
-              <a:rPr lang="en-US" sz="4000" b="1" dirty="0" smtClean="0">
-                <a:solidFill>
-                  <a:schemeClr val="tx2"/>
-                </a:solidFill>
-                <a:latin typeface="Garamond" panose="02020404030301010803" pitchFamily="18" charset="0"/>
-              </a:rPr>
-              <a:t>2026</a:t>
+              <a:t>SMART INDIA HACKATHON 2026</a:t>
             </a:r>
             <a:endParaRPr lang="en-IN" sz="4000" b="1" dirty="0">
               <a:solidFill>
@@ -5629,7 +5620,7 @@
         <p:spPr>
           <a:xfrm>
             <a:off x="331286" y="2076450"/>
-            <a:ext cx="5924550" cy="4703019"/>
+            <a:ext cx="5924550" cy="3441968"/>
           </a:xfrm>
           <a:prstGeom prst="rect">
             <a:avLst/>
@@ -5648,12 +5639,12 @@
               </a:spcAft>
             </a:pPr>
             <a:r>
-              <a:rPr sz="2200" b="1">
+              <a:rPr sz="2200" b="1" dirty="0">
                 <a:latin typeface="Arial"/>
               </a:rPr>
               <a:t>Problem Statement ID  :  26076</a:t>
             </a:r>
-            <a:endParaRPr lang="en-US"/>
+            <a:endParaRPr lang="en-US" dirty="0"/>
           </a:p>
           <a:p>
             <a:pPr>
@@ -5662,7 +5653,7 @@
               </a:spcAft>
             </a:pPr>
             <a:r>
-              <a:rPr sz="2200" b="1">
+              <a:rPr sz="2200" b="1" dirty="0">
                 <a:latin typeface="Arial"/>
               </a:rPr>
               <a:t>Problem Statement Title  :  Development of Personalized Homepage for 'Mausam' Mobile Application</a:t>
@@ -5675,7 +5666,7 @@
               </a:spcAft>
             </a:pPr>
             <a:r>
-              <a:rPr sz="2200" b="1">
+              <a:rPr sz="2200" b="1" dirty="0">
                 <a:latin typeface="Arial"/>
               </a:rPr>
               <a:t>Theme  :  Smart Automation</a:t>
@@ -5688,7 +5679,7 @@
               </a:spcAft>
             </a:pPr>
             <a:r>
-              <a:rPr sz="2200" b="1">
+              <a:rPr sz="2200" b="1" dirty="0">
                 <a:latin typeface="Arial"/>
               </a:rPr>
               <a:t>PS Category  :  Software</a:t>
@@ -5701,10 +5692,10 @@
               </a:spcAft>
             </a:pPr>
             <a:r>
-              <a:rPr sz="2200" b="1">
+              <a:rPr sz="2200" b="1" dirty="0">
                 <a:latin typeface="Arial"/>
               </a:rPr>
-              <a:t>Team ID  :  ____________ (to be filled after registration)</a:t>
+              <a:t>Team ID  : </a:t>
             </a:r>
           </a:p>
           <a:p>
@@ -5714,11 +5705,20 @@
               </a:spcAft>
             </a:pPr>
             <a:r>
-              <a:rPr sz="2200" b="1">
+              <a:rPr sz="2200" b="1" dirty="0">
                 <a:latin typeface="Arial"/>
               </a:rPr>
-              <a:t>Team Name  :  BugNotFound</a:t>
-            </a:r>
+              <a:t>Team Name  :  </a:t>
+            </a:r>
+            <a:r>
+              <a:rPr sz="2200" b="1" dirty="0" err="1">
+                <a:latin typeface="Arial"/>
+              </a:rPr>
+              <a:t>BugNotFound</a:t>
+            </a:r>
+            <a:endParaRPr sz="2200" b="1" dirty="0">
+              <a:latin typeface="Arial"/>
+            </a:endParaRPr>
           </a:p>
         </p:txBody>
       </p:sp>
@@ -5856,14 +5856,6 @@
           <a:lstStyle/>
           <a:p>
             <a:pPr eaLnBrk="1" hangingPunct="1"/>
-            <a:r>
-              <a:rPr lang="en-US" sz="3600" b="1" dirty="0">
-                <a:latin typeface="Times New Roman" panose="02020603050405020304" pitchFamily="18" charset="0"/>
-                <a:ea typeface="ＭＳ Ｐゴシック" pitchFamily="1" charset="-128"/>
-                <a:cs typeface="Times New Roman" panose="02020603050405020304" pitchFamily="18" charset="0"/>
-              </a:rPr>
-              <a:t/>
-            </a:r>
             <a:br>
               <a:rPr lang="en-US" sz="3600" b="1" dirty="0">
                 <a:latin typeface="Times New Roman" panose="02020603050405020304" pitchFamily="18" charset="0"/>
@@ -6226,7 +6218,7 @@
                 <a16:creationId xmlns:a16="http://schemas.microsoft.com/office/drawing/2014/main" id="{5DBCE864-823D-4A13-9607-5DA1F0ED5FB8}"/>
               </a:ext>
               <a:ext uri="{C183D7F6-B498-43B3-948B-1728B52AA6E4}">
-                <adec:decorative xmlns:adec="http://schemas.microsoft.com/office/drawing/2017/decorative" xmlns="" val="0"/>
+                <adec:decorative xmlns:adec="http://schemas.microsoft.com/office/drawing/2017/decorative" val="0"/>
               </a:ext>
             </a:extLst>
           </p:cNvPr>
@@ -6721,7 +6713,7 @@
                 <a16:creationId xmlns:a16="http://schemas.microsoft.com/office/drawing/2014/main" id="{5DBCE864-823D-4A13-9607-5DA1F0ED5FB8}"/>
               </a:ext>
               <a:ext uri="{C183D7F6-B498-43B3-948B-1728B52AA6E4}">
-                <adec:decorative xmlns:adec="http://schemas.microsoft.com/office/drawing/2017/decorative" xmlns="" val="0"/>
+                <adec:decorative xmlns:adec="http://schemas.microsoft.com/office/drawing/2017/decorative" val="0"/>
               </a:ext>
             </a:extLst>
           </p:cNvPr>
@@ -7314,7 +7306,7 @@
                 <a16:creationId xmlns:a16="http://schemas.microsoft.com/office/drawing/2014/main" id="{5DBCE864-823D-4A13-9607-5DA1F0ED5FB8}"/>
               </a:ext>
               <a:ext uri="{C183D7F6-B498-43B3-948B-1728B52AA6E4}">
-                <adec:decorative xmlns:adec="http://schemas.microsoft.com/office/drawing/2017/decorative" xmlns="" val="0"/>
+                <adec:decorative xmlns:adec="http://schemas.microsoft.com/office/drawing/2017/decorative" val="0"/>
               </a:ext>
             </a:extLst>
           </p:cNvPr>
@@ -7792,7 +7784,7 @@
                 <a16:creationId xmlns:a16="http://schemas.microsoft.com/office/drawing/2014/main" id="{5DBCE864-823D-4A13-9607-5DA1F0ED5FB8}"/>
               </a:ext>
               <a:ext uri="{C183D7F6-B498-43B3-948B-1728B52AA6E4}">
-                <adec:decorative xmlns:adec="http://schemas.microsoft.com/office/drawing/2017/decorative" xmlns="" val="0"/>
+                <adec:decorative xmlns:adec="http://schemas.microsoft.com/office/drawing/2017/decorative" val="0"/>
               </a:ext>
             </a:extLst>
           </p:cNvPr>
@@ -8310,7 +8302,7 @@
                 <a16:creationId xmlns:a16="http://schemas.microsoft.com/office/drawing/2014/main" id="{5DBCE864-823D-4A13-9607-5DA1F0ED5FB8}"/>
               </a:ext>
               <a:ext uri="{C183D7F6-B498-43B3-948B-1728B52AA6E4}">
-                <adec:decorative xmlns:adec="http://schemas.microsoft.com/office/drawing/2017/decorative" xmlns="" val="0"/>
+                <adec:decorative xmlns:adec="http://schemas.microsoft.com/office/drawing/2017/decorative" val="0"/>
               </a:ext>
             </a:extLst>
           </p:cNvPr>

</xml_diff>